<commit_message>
pytorch statespace meta update
</commit_message>
<xml_diff>
--- a/lessons/04_state_space/state_space.pptx
+++ b/lessons/04_state_space/state_space.pptx
@@ -211,7 +211,7 @@
           <a:p>
             <a:fld id="{99D4630A-6D3B-4C97-A7DC-509EB0048625}" type="datetimeFigureOut">
               <a:rPr lang="it-CH" smtClean="0"/>
-              <a:t>29.06.25</a:t>
+              <a:t>08.06.26</a:t>
             </a:fld>
             <a:endParaRPr lang="it-CH"/>
           </a:p>
@@ -498,7 +498,7 @@
       </p:grpSpPr>
       <p:sp>
         <p:nvSpPr>
-          <p:cNvPr id="2" name="Segnaposto immagine diapositiva 1"/>
+          <p:cNvPr id="2" name="Slide Image Placeholder 1"/>
           <p:cNvSpPr>
             <a:spLocks noGrp="1" noRot="1" noChangeAspect="1"/>
           </p:cNvSpPr>
@@ -510,7 +510,7 @@
       </p:sp>
       <p:sp>
         <p:nvSpPr>
-          <p:cNvPr id="3" name="Segnaposto note 2"/>
+          <p:cNvPr id="3" name="Notes Placeholder 2"/>
           <p:cNvSpPr>
             <a:spLocks noGrp="1"/>
           </p:cNvSpPr>
@@ -523,30 +523,13 @@
           <a:bodyPr/>
           <a:lstStyle/>
           <a:p>
-            <a:pPr marL="0" marR="0" lvl="0" indent="0" algn="l" defTabSz="914400" rtl="0" eaLnBrk="1" fontAlgn="auto" latinLnBrk="0" hangingPunct="1">
-              <a:lnSpc>
-                <a:spcPct val="100000"/>
-              </a:lnSpc>
-              <a:spcBef>
-                <a:spcPts val="0"/>
-              </a:spcBef>
-              <a:spcAft>
-                <a:spcPts val="0"/>
-              </a:spcAft>
-              <a:buClrTx/>
-              <a:buSzTx/>
-              <a:buFontTx/>
-              <a:buNone/>
-              <a:tabLst/>
-              <a:defRPr/>
-            </a:pPr>
-            <a:endParaRPr lang="it-CH" dirty="0"/>
+            <a:endParaRPr lang="en-CH" dirty="0"/>
           </a:p>
         </p:txBody>
       </p:sp>
       <p:sp>
         <p:nvSpPr>
-          <p:cNvPr id="4" name="Segnaposto numero diapositiva 3"/>
+          <p:cNvPr id="4" name="Slide Number Placeholder 3"/>
           <p:cNvSpPr>
             <a:spLocks noGrp="1"/>
           </p:cNvSpPr>
@@ -559,9 +542,9 @@
           <a:bodyPr/>
           <a:lstStyle/>
           <a:p>
-            <a:fld id="{B6A6F0FA-31D0-AB4D-9BAD-FF9E467B93C7}" type="slidenum">
+            <a:fld id="{BA8AB120-BC75-4CF8-A646-8F594D18F614}" type="slidenum">
               <a:rPr lang="it-CH" smtClean="0"/>
-              <a:t>2</a:t>
+              <a:t>1</a:t>
             </a:fld>
             <a:endParaRPr lang="it-CH"/>
           </a:p>
@@ -570,7 +553,7 @@
     </p:spTree>
     <p:extLst>
       <p:ext uri="{BB962C8B-B14F-4D97-AF65-F5344CB8AC3E}">
-        <p14:creationId xmlns:p14="http://schemas.microsoft.com/office/powerpoint/2010/main" val="2060908397"/>
+        <p14:creationId xmlns:p14="http://schemas.microsoft.com/office/powerpoint/2010/main" val="2986458285"/>
       </p:ext>
     </p:extLst>
   </p:cSld>
@@ -641,10 +624,7 @@
               <a:tabLst/>
               <a:defRPr/>
             </a:pPr>
-            <a:r>
-              <a:rPr lang="it-CH" dirty="0"/>
-              <a:t>https://github.com/pytorch/examples/blob/main/word_language_model/main.py</a:t>
-            </a:r>
+            <a:endParaRPr lang="it-CH" dirty="0"/>
           </a:p>
         </p:txBody>
       </p:sp>
@@ -665,7 +645,7 @@
           <a:p>
             <a:fld id="{B6A6F0FA-31D0-AB4D-9BAD-FF9E467B93C7}" type="slidenum">
               <a:rPr lang="it-CH" smtClean="0"/>
-              <a:t>11</a:t>
+              <a:t>10</a:t>
             </a:fld>
             <a:endParaRPr lang="it-CH"/>
           </a:p>
@@ -674,7 +654,7 @@
     </p:spTree>
     <p:extLst>
       <p:ext uri="{BB962C8B-B14F-4D97-AF65-F5344CB8AC3E}">
-        <p14:creationId xmlns:p14="http://schemas.microsoft.com/office/powerpoint/2010/main" val="1508865141"/>
+        <p14:creationId xmlns:p14="http://schemas.microsoft.com/office/powerpoint/2010/main" val="239136211"/>
       </p:ext>
     </p:extLst>
   </p:cSld>
@@ -769,7 +749,7 @@
           <a:p>
             <a:fld id="{B6A6F0FA-31D0-AB4D-9BAD-FF9E467B93C7}" type="slidenum">
               <a:rPr lang="it-CH" smtClean="0"/>
-              <a:t>12</a:t>
+              <a:t>11</a:t>
             </a:fld>
             <a:endParaRPr lang="it-CH"/>
           </a:p>
@@ -778,7 +758,7 @@
     </p:spTree>
     <p:extLst>
       <p:ext uri="{BB962C8B-B14F-4D97-AF65-F5344CB8AC3E}">
-        <p14:creationId xmlns:p14="http://schemas.microsoft.com/office/powerpoint/2010/main" val="3125060051"/>
+        <p14:creationId xmlns:p14="http://schemas.microsoft.com/office/powerpoint/2010/main" val="1508865141"/>
       </p:ext>
     </p:extLst>
   </p:cSld>
@@ -873,6 +853,110 @@
           <a:p>
             <a:fld id="{B6A6F0FA-31D0-AB4D-9BAD-FF9E467B93C7}" type="slidenum">
               <a:rPr lang="it-CH" smtClean="0"/>
+              <a:t>12</a:t>
+            </a:fld>
+            <a:endParaRPr lang="it-CH"/>
+          </a:p>
+        </p:txBody>
+      </p:sp>
+    </p:spTree>
+    <p:extLst>
+      <p:ext uri="{BB962C8B-B14F-4D97-AF65-F5344CB8AC3E}">
+        <p14:creationId xmlns:p14="http://schemas.microsoft.com/office/powerpoint/2010/main" val="3125060051"/>
+      </p:ext>
+    </p:extLst>
+  </p:cSld>
+  <p:clrMapOvr>
+    <a:masterClrMapping/>
+  </p:clrMapOvr>
+</p:notes>
+</file>
+
+<file path=ppt/notesSlides/notesSlide13.xml><?xml version="1.0" encoding="utf-8"?>
+<p:notes xmlns:a="http://schemas.openxmlformats.org/drawingml/2006/main" xmlns:r="http://schemas.openxmlformats.org/officeDocument/2006/relationships" xmlns:p="http://schemas.openxmlformats.org/presentationml/2006/main">
+  <p:cSld>
+    <p:spTree>
+      <p:nvGrpSpPr>
+        <p:cNvPr id="1" name=""/>
+        <p:cNvGrpSpPr/>
+        <p:nvPr/>
+      </p:nvGrpSpPr>
+      <p:grpSpPr>
+        <a:xfrm>
+          <a:off x="0" y="0"/>
+          <a:ext cx="0" cy="0"/>
+          <a:chOff x="0" y="0"/>
+          <a:chExt cx="0" cy="0"/>
+        </a:xfrm>
+      </p:grpSpPr>
+      <p:sp>
+        <p:nvSpPr>
+          <p:cNvPr id="2" name="Segnaposto immagine diapositiva 1"/>
+          <p:cNvSpPr>
+            <a:spLocks noGrp="1" noRot="1" noChangeAspect="1"/>
+          </p:cNvSpPr>
+          <p:nvPr>
+            <p:ph type="sldImg"/>
+          </p:nvPr>
+        </p:nvSpPr>
+        <p:spPr/>
+      </p:sp>
+      <p:sp>
+        <p:nvSpPr>
+          <p:cNvPr id="3" name="Segnaposto note 2"/>
+          <p:cNvSpPr>
+            <a:spLocks noGrp="1"/>
+          </p:cNvSpPr>
+          <p:nvPr>
+            <p:ph type="body" idx="1"/>
+          </p:nvPr>
+        </p:nvSpPr>
+        <p:spPr/>
+        <p:txBody>
+          <a:bodyPr/>
+          <a:lstStyle/>
+          <a:p>
+            <a:pPr marL="0" marR="0" lvl="0" indent="0" algn="l" defTabSz="914400" rtl="0" eaLnBrk="1" fontAlgn="auto" latinLnBrk="0" hangingPunct="1">
+              <a:lnSpc>
+                <a:spcPct val="100000"/>
+              </a:lnSpc>
+              <a:spcBef>
+                <a:spcPts val="0"/>
+              </a:spcBef>
+              <a:spcAft>
+                <a:spcPts val="0"/>
+              </a:spcAft>
+              <a:buClrTx/>
+              <a:buSzTx/>
+              <a:buFontTx/>
+              <a:buNone/>
+              <a:tabLst/>
+              <a:defRPr/>
+            </a:pPr>
+            <a:r>
+              <a:rPr lang="it-CH" dirty="0"/>
+              <a:t>https://github.com/pytorch/examples/blob/main/word_language_model/main.py</a:t>
+            </a:r>
+          </a:p>
+        </p:txBody>
+      </p:sp>
+      <p:sp>
+        <p:nvSpPr>
+          <p:cNvPr id="4" name="Segnaposto numero diapositiva 3"/>
+          <p:cNvSpPr>
+            <a:spLocks noGrp="1"/>
+          </p:cNvSpPr>
+          <p:nvPr>
+            <p:ph type="sldNum" sz="quarter" idx="5"/>
+          </p:nvPr>
+        </p:nvSpPr>
+        <p:spPr/>
+        <p:txBody>
+          <a:bodyPr/>
+          <a:lstStyle/>
+          <a:p>
+            <a:fld id="{B6A6F0FA-31D0-AB4D-9BAD-FF9E467B93C7}" type="slidenum">
+              <a:rPr lang="it-CH" smtClean="0"/>
               <a:t>13</a:t>
             </a:fld>
             <a:endParaRPr lang="it-CH"/>
@@ -892,7 +976,7 @@
 </p:notes>
 </file>
 
-<file path=ppt/notesSlides/notesSlide13.xml><?xml version="1.0" encoding="utf-8"?>
+<file path=ppt/notesSlides/notesSlide14.xml><?xml version="1.0" encoding="utf-8"?>
 <p:notes xmlns:a="http://schemas.openxmlformats.org/drawingml/2006/main" xmlns:r="http://schemas.openxmlformats.org/officeDocument/2006/relationships" xmlns:p="http://schemas.openxmlformats.org/presentationml/2006/main">
   <p:cSld>
     <p:spTree>
@@ -1102,7 +1186,7 @@
           <a:p>
             <a:fld id="{B6A6F0FA-31D0-AB4D-9BAD-FF9E467B93C7}" type="slidenum">
               <a:rPr lang="it-CH" smtClean="0"/>
-              <a:t>3</a:t>
+              <a:t>2</a:t>
             </a:fld>
             <a:endParaRPr lang="it-CH"/>
           </a:p>
@@ -1111,7 +1195,7 @@
     </p:spTree>
     <p:extLst>
       <p:ext uri="{BB962C8B-B14F-4D97-AF65-F5344CB8AC3E}">
-        <p14:creationId xmlns:p14="http://schemas.microsoft.com/office/powerpoint/2010/main" val="2831885375"/>
+        <p14:creationId xmlns:p14="http://schemas.microsoft.com/office/powerpoint/2010/main" val="2060908397"/>
       </p:ext>
     </p:extLst>
   </p:cSld>
@@ -1203,7 +1287,7 @@
           <a:p>
             <a:fld id="{B6A6F0FA-31D0-AB4D-9BAD-FF9E467B93C7}" type="slidenum">
               <a:rPr lang="it-CH" smtClean="0"/>
-              <a:t>4</a:t>
+              <a:t>3</a:t>
             </a:fld>
             <a:endParaRPr lang="it-CH"/>
           </a:p>
@@ -1212,7 +1296,7 @@
     </p:spTree>
     <p:extLst>
       <p:ext uri="{BB962C8B-B14F-4D97-AF65-F5344CB8AC3E}">
-        <p14:creationId xmlns:p14="http://schemas.microsoft.com/office/powerpoint/2010/main" val="2332360066"/>
+        <p14:creationId xmlns:p14="http://schemas.microsoft.com/office/powerpoint/2010/main" val="2831885375"/>
       </p:ext>
     </p:extLst>
   </p:cSld>
@@ -1304,7 +1388,7 @@
           <a:p>
             <a:fld id="{B6A6F0FA-31D0-AB4D-9BAD-FF9E467B93C7}" type="slidenum">
               <a:rPr lang="it-CH" smtClean="0"/>
-              <a:t>5</a:t>
+              <a:t>4</a:t>
             </a:fld>
             <a:endParaRPr lang="it-CH"/>
           </a:p>
@@ -1313,7 +1397,7 @@
     </p:spTree>
     <p:extLst>
       <p:ext uri="{BB962C8B-B14F-4D97-AF65-F5344CB8AC3E}">
-        <p14:creationId xmlns:p14="http://schemas.microsoft.com/office/powerpoint/2010/main" val="279698290"/>
+        <p14:creationId xmlns:p14="http://schemas.microsoft.com/office/powerpoint/2010/main" val="2332360066"/>
       </p:ext>
     </p:extLst>
   </p:cSld>
@@ -1405,7 +1489,7 @@
           <a:p>
             <a:fld id="{B6A6F0FA-31D0-AB4D-9BAD-FF9E467B93C7}" type="slidenum">
               <a:rPr lang="it-CH" smtClean="0"/>
-              <a:t>6</a:t>
+              <a:t>5</a:t>
             </a:fld>
             <a:endParaRPr lang="it-CH"/>
           </a:p>
@@ -1414,7 +1498,7 @@
     </p:spTree>
     <p:extLst>
       <p:ext uri="{BB962C8B-B14F-4D97-AF65-F5344CB8AC3E}">
-        <p14:creationId xmlns:p14="http://schemas.microsoft.com/office/powerpoint/2010/main" val="61968282"/>
+        <p14:creationId xmlns:p14="http://schemas.microsoft.com/office/powerpoint/2010/main" val="279698290"/>
       </p:ext>
     </p:extLst>
   </p:cSld>
@@ -1506,7 +1590,7 @@
           <a:p>
             <a:fld id="{B6A6F0FA-31D0-AB4D-9BAD-FF9E467B93C7}" type="slidenum">
               <a:rPr lang="it-CH" smtClean="0"/>
-              <a:t>7</a:t>
+              <a:t>6</a:t>
             </a:fld>
             <a:endParaRPr lang="it-CH"/>
           </a:p>
@@ -1515,7 +1599,7 @@
     </p:spTree>
     <p:extLst>
       <p:ext uri="{BB962C8B-B14F-4D97-AF65-F5344CB8AC3E}">
-        <p14:creationId xmlns:p14="http://schemas.microsoft.com/office/powerpoint/2010/main" val="3659142773"/>
+        <p14:creationId xmlns:p14="http://schemas.microsoft.com/office/powerpoint/2010/main" val="61968282"/>
       </p:ext>
     </p:extLst>
   </p:cSld>
@@ -1607,7 +1691,7 @@
           <a:p>
             <a:fld id="{B6A6F0FA-31D0-AB4D-9BAD-FF9E467B93C7}" type="slidenum">
               <a:rPr lang="it-CH" smtClean="0"/>
-              <a:t>8</a:t>
+              <a:t>7</a:t>
             </a:fld>
             <a:endParaRPr lang="it-CH"/>
           </a:p>
@@ -1616,7 +1700,7 @@
     </p:spTree>
     <p:extLst>
       <p:ext uri="{BB962C8B-B14F-4D97-AF65-F5344CB8AC3E}">
-        <p14:creationId xmlns:p14="http://schemas.microsoft.com/office/powerpoint/2010/main" val="4120822504"/>
+        <p14:creationId xmlns:p14="http://schemas.microsoft.com/office/powerpoint/2010/main" val="3659142773"/>
       </p:ext>
     </p:extLst>
   </p:cSld>
@@ -1708,7 +1792,7 @@
           <a:p>
             <a:fld id="{B6A6F0FA-31D0-AB4D-9BAD-FF9E467B93C7}" type="slidenum">
               <a:rPr lang="it-CH" smtClean="0"/>
-              <a:t>9</a:t>
+              <a:t>8</a:t>
             </a:fld>
             <a:endParaRPr lang="it-CH"/>
           </a:p>
@@ -1717,7 +1801,7 @@
     </p:spTree>
     <p:extLst>
       <p:ext uri="{BB962C8B-B14F-4D97-AF65-F5344CB8AC3E}">
-        <p14:creationId xmlns:p14="http://schemas.microsoft.com/office/powerpoint/2010/main" val="1112727817"/>
+        <p14:creationId xmlns:p14="http://schemas.microsoft.com/office/powerpoint/2010/main" val="4120822504"/>
       </p:ext>
     </p:extLst>
   </p:cSld>
@@ -1809,7 +1893,7 @@
           <a:p>
             <a:fld id="{B6A6F0FA-31D0-AB4D-9BAD-FF9E467B93C7}" type="slidenum">
               <a:rPr lang="it-CH" smtClean="0"/>
-              <a:t>10</a:t>
+              <a:t>9</a:t>
             </a:fld>
             <a:endParaRPr lang="it-CH"/>
           </a:p>
@@ -1818,7 +1902,7 @@
     </p:spTree>
     <p:extLst>
       <p:ext uri="{BB962C8B-B14F-4D97-AF65-F5344CB8AC3E}">
-        <p14:creationId xmlns:p14="http://schemas.microsoft.com/office/powerpoint/2010/main" val="239136211"/>
+        <p14:creationId xmlns:p14="http://schemas.microsoft.com/office/powerpoint/2010/main" val="1112727817"/>
       </p:ext>
     </p:extLst>
   </p:cSld>
@@ -1980,7 +2064,7 @@
           <a:p>
             <a:fld id="{2A147C38-CC24-4E9D-9FE1-BE5105214113}" type="datetimeFigureOut">
               <a:rPr lang="it-CH" smtClean="0"/>
-              <a:t>29.06.25</a:t>
+              <a:t>08.06.26</a:t>
             </a:fld>
             <a:endParaRPr lang="it-CH"/>
           </a:p>
@@ -2188,7 +2272,7 @@
           <a:p>
             <a:fld id="{2A147C38-CC24-4E9D-9FE1-BE5105214113}" type="datetimeFigureOut">
               <a:rPr lang="it-CH" smtClean="0"/>
-              <a:t>29.06.25</a:t>
+              <a:t>08.06.26</a:t>
             </a:fld>
             <a:endParaRPr lang="it-CH"/>
           </a:p>
@@ -2401,7 +2485,7 @@
           <a:p>
             <a:fld id="{2A147C38-CC24-4E9D-9FE1-BE5105214113}" type="datetimeFigureOut">
               <a:rPr lang="it-CH" smtClean="0"/>
-              <a:t>29.06.25</a:t>
+              <a:t>08.06.26</a:t>
             </a:fld>
             <a:endParaRPr lang="it-CH"/>
           </a:p>
@@ -2732,7 +2816,7 @@
           <a:p>
             <a:fld id="{2A147C38-CC24-4E9D-9FE1-BE5105214113}" type="datetimeFigureOut">
               <a:rPr lang="it-CH" smtClean="0"/>
-              <a:t>29.06.25</a:t>
+              <a:t>08.06.26</a:t>
             </a:fld>
             <a:endParaRPr lang="it-CH"/>
           </a:p>
@@ -3011,7 +3095,7 @@
           <a:p>
             <a:fld id="{2A147C38-CC24-4E9D-9FE1-BE5105214113}" type="datetimeFigureOut">
               <a:rPr lang="it-CH" smtClean="0"/>
-              <a:t>29.06.25</a:t>
+              <a:t>08.06.26</a:t>
             </a:fld>
             <a:endParaRPr lang="it-CH"/>
           </a:p>
@@ -3287,7 +3371,7 @@
           <a:p>
             <a:fld id="{2A147C38-CC24-4E9D-9FE1-BE5105214113}" type="datetimeFigureOut">
               <a:rPr lang="it-CH" smtClean="0"/>
-              <a:t>29.06.25</a:t>
+              <a:t>08.06.26</a:t>
             </a:fld>
             <a:endParaRPr lang="it-CH"/>
           </a:p>
@@ -3705,7 +3789,7 @@
           <a:p>
             <a:fld id="{2A147C38-CC24-4E9D-9FE1-BE5105214113}" type="datetimeFigureOut">
               <a:rPr lang="it-CH" smtClean="0"/>
-              <a:t>29.06.25</a:t>
+              <a:t>08.06.26</a:t>
             </a:fld>
             <a:endParaRPr lang="it-CH"/>
           </a:p>
@@ -3855,7 +3939,7 @@
           <a:p>
             <a:fld id="{2A147C38-CC24-4E9D-9FE1-BE5105214113}" type="datetimeFigureOut">
               <a:rPr lang="it-CH" smtClean="0"/>
-              <a:t>29.06.25</a:t>
+              <a:t>08.06.26</a:t>
             </a:fld>
             <a:endParaRPr lang="it-CH"/>
           </a:p>
@@ -3968,7 +4052,7 @@
           <a:p>
             <a:fld id="{2A147C38-CC24-4E9D-9FE1-BE5105214113}" type="datetimeFigureOut">
               <a:rPr lang="it-CH" smtClean="0"/>
-              <a:t>29.06.25</a:t>
+              <a:t>08.06.26</a:t>
             </a:fld>
             <a:endParaRPr lang="it-CH"/>
           </a:p>
@@ -4284,7 +4368,7 @@
           <a:p>
             <a:fld id="{2A147C38-CC24-4E9D-9FE1-BE5105214113}" type="datetimeFigureOut">
               <a:rPr lang="it-CH" smtClean="0"/>
-              <a:t>29.06.25</a:t>
+              <a:t>08.06.26</a:t>
             </a:fld>
             <a:endParaRPr lang="it-CH"/>
           </a:p>
@@ -4576,7 +4660,7 @@
           <a:p>
             <a:fld id="{2A147C38-CC24-4E9D-9FE1-BE5105214113}" type="datetimeFigureOut">
               <a:rPr lang="it-CH" smtClean="0"/>
-              <a:t>29.06.25</a:t>
+              <a:t>08.06.26</a:t>
             </a:fld>
             <a:endParaRPr lang="it-CH"/>
           </a:p>
@@ -4819,7 +4903,7 @@
           <a:p>
             <a:fld id="{2A147C38-CC24-4E9D-9FE1-BE5105214113}" type="datetimeFigureOut">
               <a:rPr lang="it-CH" smtClean="0"/>
-              <a:t>29.06.25</a:t>
+              <a:t>08.06.26</a:t>
             </a:fld>
             <a:endParaRPr lang="it-CH"/>
           </a:p>
@@ -5275,7 +5359,7 @@
         <p:spPr>
           <a:xfrm>
             <a:off x="355801" y="3190028"/>
-            <a:ext cx="11712374" cy="2991396"/>
+            <a:ext cx="11712374" cy="2765244"/>
           </a:xfrm>
           <a:prstGeom prst="rect">
             <a:avLst/>
@@ -5329,75 +5413,43 @@
                 <a:spcPct val="150000"/>
               </a:lnSpc>
             </a:pPr>
+            <a:endParaRPr lang="en-US" sz="2400" dirty="0">
+              <a:solidFill>
+                <a:schemeClr val="accent1">
+                  <a:lumMod val="75000"/>
+                </a:schemeClr>
+              </a:solidFill>
+            </a:endParaRPr>
+          </a:p>
+          <a:p>
+            <a:pPr>
+              <a:lnSpc>
+                <a:spcPct val="150000"/>
+              </a:lnSpc>
+            </a:pPr>
             <a:r>
               <a:rPr lang="en-US" sz="1600" dirty="0">
                 <a:latin typeface="Trebuchet MS" charset="0"/>
                 <a:ea typeface="Trebuchet MS" charset="0"/>
                 <a:cs typeface="Trebuchet MS" charset="0"/>
               </a:rPr>
-              <a:t>Marco Forgione, </a:t>
+              <a:t>Marco Forgione, Dalle Molle Institute for Artificial Intelligence, Lugano, Switzerland</a:t>
             </a:r>
-            <a:r>
-              <a:rPr lang="en-US" sz="1600" dirty="0" err="1">
-                <a:latin typeface="Trebuchet MS" charset="0"/>
-                <a:ea typeface="Trebuchet MS" charset="0"/>
-                <a:cs typeface="Trebuchet MS" charset="0"/>
-              </a:rPr>
-              <a:t>Dalle</a:t>
-            </a:r>
+          </a:p>
+          <a:p>
+            <a:pPr>
+              <a:lnSpc>
+                <a:spcPct val="150000"/>
+              </a:lnSpc>
+            </a:pPr>
             <a:r>
               <a:rPr lang="en-US" sz="1600" dirty="0">
                 <a:latin typeface="Trebuchet MS" charset="0"/>
                 <a:ea typeface="Trebuchet MS" charset="0"/>
                 <a:cs typeface="Trebuchet MS" charset="0"/>
               </a:rPr>
-              <a:t> </a:t>
+              <a:t>Leuven, June 17, 2026 </a:t>
             </a:r>
-            <a:r>
-              <a:rPr lang="en-US" sz="1600" dirty="0" err="1">
-                <a:latin typeface="Trebuchet MS" charset="0"/>
-                <a:ea typeface="Trebuchet MS" charset="0"/>
-                <a:cs typeface="Trebuchet MS" charset="0"/>
-              </a:rPr>
-              <a:t>Molle</a:t>
-            </a:r>
-            <a:r>
-              <a:rPr lang="en-US" sz="1600" dirty="0">
-                <a:latin typeface="Trebuchet MS" charset="0"/>
-                <a:ea typeface="Trebuchet MS" charset="0"/>
-                <a:cs typeface="Trebuchet MS" charset="0"/>
-              </a:rPr>
-              <a:t> Institute for Artificial Intelligence, Lugano, Switzerland</a:t>
-            </a:r>
-          </a:p>
-          <a:p>
-            <a:pPr>
-              <a:lnSpc>
-                <a:spcPct val="150000"/>
-              </a:lnSpc>
-            </a:pPr>
-            <a:endParaRPr lang="en-US" dirty="0">
-              <a:latin typeface="Trebuchet MS" charset="0"/>
-              <a:ea typeface="Trebuchet MS" charset="0"/>
-              <a:cs typeface="Trebuchet MS" charset="0"/>
-            </a:endParaRPr>
-          </a:p>
-          <a:p>
-            <a:pPr>
-              <a:lnSpc>
-                <a:spcPct val="150000"/>
-              </a:lnSpc>
-            </a:pPr>
-            <a:endParaRPr lang="en-US" sz="3600" b="1" dirty="0">
-              <a:solidFill>
-                <a:schemeClr val="accent1">
-                  <a:lumMod val="75000"/>
-                </a:schemeClr>
-              </a:solidFill>
-              <a:latin typeface="Trebuchet MS" charset="0"/>
-              <a:ea typeface="Trebuchet MS" charset="0"/>
-              <a:cs typeface="Trebuchet MS" charset="0"/>
-            </a:endParaRPr>
           </a:p>
         </p:txBody>
       </p:sp>
@@ -5410,7 +5462,7 @@
           <p:nvPr/>
         </p:nvPicPr>
         <p:blipFill>
-          <a:blip r:embed="rId2" cstate="print">
+          <a:blip r:embed="rId3" cstate="print">
             <a:extLst>
               <a:ext uri="{28A0092B-C50C-407E-A947-70E740481C1C}">
                 <a14:useLocalDpi xmlns:a14="http://schemas.microsoft.com/office/drawing/2010/main" val="0"/>
@@ -5464,7 +5516,7 @@
           <p:nvPr/>
         </p:nvPicPr>
         <p:blipFill>
-          <a:blip r:embed="rId3" cstate="hqprint">
+          <a:blip r:embed="rId4" cstate="hqprint">
             <a:extLst>
               <a:ext uri="{28A0092B-C50C-407E-A947-70E740481C1C}">
                 <a14:useLocalDpi xmlns:a14="http://schemas.microsoft.com/office/drawing/2010/main" val="0"/>
@@ -5511,7 +5563,7 @@
           <p:nvPr/>
         </p:nvPicPr>
         <p:blipFill>
-          <a:blip r:embed="rId4" cstate="hqprint">
+          <a:blip r:embed="rId5" cstate="hqprint">
             <a:extLst>
               <a:ext uri="{28A0092B-C50C-407E-A947-70E740481C1C}">
                 <a14:useLocalDpi xmlns:a14="http://schemas.microsoft.com/office/drawing/2010/main" val="0"/>
@@ -5532,42 +5584,6 @@
           </a:prstGeom>
         </p:spPr>
       </p:pic>
-      <p:sp>
-        <p:nvSpPr>
-          <p:cNvPr id="10" name="Rechteck 5"/>
-          <p:cNvSpPr/>
-          <p:nvPr/>
-        </p:nvSpPr>
-        <p:spPr>
-          <a:xfrm>
-            <a:off x="387985" y="6365820"/>
-            <a:ext cx="2233432" cy="369332"/>
-          </a:xfrm>
-          <a:prstGeom prst="rect">
-            <a:avLst/>
-          </a:prstGeom>
-        </p:spPr>
-        <p:txBody>
-          <a:bodyPr wrap="none">
-            <a:spAutoFit/>
-          </a:bodyPr>
-          <a:lstStyle/>
-          <a:p>
-            <a:r>
-              <a:rPr lang="en-US" dirty="0"/>
-              <a:t>Milano, July 3</a:t>
-            </a:r>
-            <a:r>
-              <a:rPr lang="en-US" baseline="30000" dirty="0"/>
-              <a:t>rd</a:t>
-            </a:r>
-            <a:r>
-              <a:rPr lang="en-US" dirty="0"/>
-              <a:t>, 2025 </a:t>
-            </a:r>
-          </a:p>
-        </p:txBody>
-      </p:sp>
     </p:spTree>
     <p:extLst>
       <p:ext uri="{BB962C8B-B14F-4D97-AF65-F5344CB8AC3E}">
@@ -11567,8 +11583,8 @@
           </a:fontRef>
         </p:style>
       </p:cxnSp>
-      <mc:AlternateContent xmlns:mc="http://schemas.openxmlformats.org/markup-compatibility/2006">
-        <mc:Choice xmlns:a14="http://schemas.microsoft.com/office/drawing/2010/main" Requires="a14">
+      <mc:AlternateContent xmlns:mc="http://schemas.openxmlformats.org/markup-compatibility/2006" xmlns:a14="http://schemas.microsoft.com/office/drawing/2010/main">
+        <mc:Choice Requires="a14">
           <p:sp>
             <p:nvSpPr>
               <p:cNvPr id="2" name="CasellaDiTesto 1">
@@ -11816,7 +11832,7 @@
             </p:txBody>
           </p:sp>
         </mc:Choice>
-        <mc:Fallback>
+        <mc:Fallback xmlns="">
           <p:sp>
             <p:nvSpPr>
               <p:cNvPr id="2" name="CasellaDiTesto 1">
@@ -12482,8 +12498,8 @@
           </a:fontRef>
         </p:style>
       </p:cxnSp>
-      <mc:AlternateContent xmlns:mc="http://schemas.openxmlformats.org/markup-compatibility/2006">
-        <mc:Choice xmlns:a14="http://schemas.microsoft.com/office/drawing/2010/main" Requires="a14">
+      <mc:AlternateContent xmlns:mc="http://schemas.openxmlformats.org/markup-compatibility/2006" xmlns:a14="http://schemas.microsoft.com/office/drawing/2010/main">
+        <mc:Choice Requires="a14">
           <p:sp>
             <p:nvSpPr>
               <p:cNvPr id="2" name="CasellaDiTesto 1">
@@ -12663,7 +12679,7 @@
             </p:txBody>
           </p:sp>
         </mc:Choice>
-        <mc:Fallback>
+        <mc:Fallback xmlns="">
           <p:sp>
             <p:nvSpPr>
               <p:cNvPr id="2" name="CasellaDiTesto 1">
@@ -12723,10 +12739,10 @@
           <p:nvPr/>
         </p:nvPicPr>
         <p:blipFill>
-          <a:blip r:embed="rId4">
+          <a:blip>
             <a:extLst>
               <a:ext uri="{96DAC541-7B7A-43D3-8B79-37D633B846F1}">
-                <asvg:svgBlip xmlns:asvg="http://schemas.microsoft.com/office/drawing/2016/SVG/main" r:embed="rId5"/>
+                <asvg:svgBlip xmlns:asvg="http://schemas.microsoft.com/office/drawing/2016/SVG/main" r:embed="rId4"/>
               </a:ext>
             </a:extLst>
           </a:blip>
@@ -12946,8 +12962,8 @@
           </a:fontRef>
         </p:style>
       </p:cxnSp>
-      <mc:AlternateContent xmlns:mc="http://schemas.openxmlformats.org/markup-compatibility/2006">
-        <mc:Choice xmlns:a14="http://schemas.microsoft.com/office/drawing/2010/main" Requires="a14">
+      <mc:AlternateContent xmlns:mc="http://schemas.openxmlformats.org/markup-compatibility/2006" xmlns:a14="http://schemas.microsoft.com/office/drawing/2010/main">
+        <mc:Choice Requires="a14">
           <p:sp>
             <p:nvSpPr>
               <p:cNvPr id="2" name="CasellaDiTesto 1">
@@ -13088,7 +13104,7 @@
             </p:txBody>
           </p:sp>
         </mc:Choice>
-        <mc:Fallback>
+        <mc:Fallback xmlns="">
           <p:sp>
             <p:nvSpPr>
               <p:cNvPr id="2" name="CasellaDiTesto 1">
@@ -13224,10 +13240,10 @@
           <p:nvPr/>
         </p:nvPicPr>
         <p:blipFill>
-          <a:blip r:embed="rId8">
+          <a:blip>
             <a:extLst>
               <a:ext uri="{96DAC541-7B7A-43D3-8B79-37D633B846F1}">
-                <asvg:svgBlip xmlns:asvg="http://schemas.microsoft.com/office/drawing/2016/SVG/main" r:embed="rId9"/>
+                <asvg:svgBlip xmlns:asvg="http://schemas.microsoft.com/office/drawing/2016/SVG/main" r:embed="rId8"/>
               </a:ext>
             </a:extLst>
           </a:blip>
@@ -13412,8 +13428,8 @@
           </a:fontRef>
         </p:style>
       </p:cxnSp>
-      <mc:AlternateContent xmlns:mc="http://schemas.openxmlformats.org/markup-compatibility/2006">
-        <mc:Choice xmlns:a14="http://schemas.microsoft.com/office/drawing/2010/main" Requires="a14">
+      <mc:AlternateContent xmlns:mc="http://schemas.openxmlformats.org/markup-compatibility/2006" xmlns:a14="http://schemas.microsoft.com/office/drawing/2010/main">
+        <mc:Choice Requires="a14">
           <p:sp>
             <p:nvSpPr>
               <p:cNvPr id="2" name="CasellaDiTesto 1">
@@ -13568,7 +13584,7 @@
             </p:txBody>
           </p:sp>
         </mc:Choice>
-        <mc:Fallback>
+        <mc:Fallback xmlns="">
           <p:sp>
             <p:nvSpPr>
               <p:cNvPr id="2" name="CasellaDiTesto 1">
@@ -13628,10 +13644,10 @@
           <p:nvPr/>
         </p:nvPicPr>
         <p:blipFill>
-          <a:blip r:embed="rId5">
+          <a:blip>
             <a:extLst>
               <a:ext uri="{96DAC541-7B7A-43D3-8B79-37D633B846F1}">
-                <asvg:svgBlip xmlns:asvg="http://schemas.microsoft.com/office/drawing/2016/SVG/main" r:embed="rId6"/>
+                <asvg:svgBlip xmlns:asvg="http://schemas.microsoft.com/office/drawing/2016/SVG/main" r:embed="rId5"/>
               </a:ext>
             </a:extLst>
           </a:blip>

</xml_diff>